<commit_message>
add ToN input conflict audit to slides
</commit_message>
<xml_diff>
--- a/docs/slides/kor/20261029_PCAP_연구방향.pptx
+++ b/docs/slides/kor/20261029_PCAP_연구방향.pptx
@@ -777,7 +777,7 @@
           </a:p>
           <a:p>
             <a:r>
-              <a:t>이 슬라이드는 NF-v3 파생 입력이 아니라 원본 CIC2018 CICFlowMeter CSV 10개 파일 전체를 직접 감사한 결과다. Timestamp와 IP·flow 식별자를 제외하고, 모든 파일에 공통인 78개 통계 field가 같은 행을 묶었다. 위 표는 그중 실제 원본 CSV 값이며, 보이는 열과 생략한 68개 field가 모두 같지만 label은 다르다. 아래 왼쪽은 이런 그룹에 속한 전체 행의 비율을, 오른쪽은 해당 행 수가 큰 label 여섯 개의 클래스 내 비율을 보인다. 이 값은 모든 충돌을 같은 단일 원인이나 모든 라벨 오류로 단정하지 않는다. 다만 동일 통계 입력으로 하나의 분류기가 두 label을 동시에 맞힐 수 없으므로, 표현과 라벨 생성 근거를 함께 다시 점검해야 함을 보여 준다.</a:t>
+              <a:t>위 표와 왼쪽 막대는 NF-v3 파생 입력이 아니라 원본 CIC2018 CICFlowMeter CSV 10개 파일 전체를 직접 감사한 결과다. Timestamp와 flow 식별자를 제외하고 모든 파일에 공통인 78개 통계 field가 같은 행을 묶었다. 위 표는 실제 원본 CSV 값이며, 보이는 열과 생략한 69개 field가 모두 같지만 label은 다르다. 오른쪽 ToN-IoT 막대는 원본 PCAP이나 모든 CSV field가 아니라 현재 실험이 쓰는 NF-v3 46개 input field와 Attack label로 계산했다. 두 막대는 상이 label feature group에 속한 행 수로 내림차순 정렬했고, 끝 숫자는 클래스 내 비율이다. 이 값은 모든 충돌을 같은 단일 원인이나 모든 라벨 오류로 단정하지 않는다. 다만 동일 통계 입력으로 하나의 분류기가 두 label을 동시에 맞힐 수 없으므로, 표현과 라벨 생성 근거를 함께 다시 점검해야 함을 보여 준다.</a:t>
             </a:r>
           </a:p>
           <a:p/>
@@ -6486,7 +6486,7 @@
         <p:spPr>
           <a:xfrm>
             <a:off x="594360" y="1719072"/>
-            <a:ext cx="5276088" cy="2496312"/>
+            <a:ext cx="5276088" cy="3355848"/>
           </a:xfrm>
           <a:prstGeom prst="rect">
             <a:avLst/>
@@ -6744,7 +6744,7 @@
         <p:spPr>
           <a:xfrm>
             <a:off x="6318504" y="1719072"/>
-            <a:ext cx="5276088" cy="2496312"/>
+            <a:ext cx="5276088" cy="3355848"/>
           </a:xfrm>
           <a:prstGeom prst="rect">
             <a:avLst/>
@@ -7001,196 +7001,6 @@
         </p:nvSpPr>
         <p:spPr>
           <a:xfrm>
-            <a:off x="594360" y="4773168"/>
-            <a:ext cx="11000232" cy="1005840"/>
-          </a:xfrm>
-          <a:prstGeom prst="rect">
-            <a:avLst/>
-          </a:prstGeom>
-          <a:solidFill>
-            <a:srgbClr val="F6F9FC"/>
-          </a:solidFill>
-          <a:ln w="10160">
-            <a:solidFill>
-              <a:srgbClr val="D3DFE9"/>
-            </a:solidFill>
-          </a:ln>
-          <a:effectLst/>
-        </p:spPr>
-        <p:style>
-          <a:lnRef idx="1">
-            <a:schemeClr val="accent1"/>
-          </a:lnRef>
-          <a:fillRef idx="3">
-            <a:schemeClr val="accent1"/>
-          </a:fillRef>
-          <a:effectRef idx="0">
-            <a:schemeClr val="accent1"/>
-          </a:effectRef>
-          <a:fontRef idx="minor">
-            <a:schemeClr val="lt1"/>
-          </a:fontRef>
-        </p:style>
-        <p:txBody>
-          <a:bodyPr rtlCol="0" anchor="ctr"/>
-          <a:lstStyle/>
-          <a:p>
-            <a:pPr algn="ctr"/>
-          </a:p>
-        </p:txBody>
-      </p:sp>
-      <p:sp>
-        <p:nvSpPr>
-          <p:cNvPr id="12" name="TextBox 11"/>
-          <p:cNvSpPr txBox="1"/>
-          <p:nvPr/>
-        </p:nvSpPr>
-        <p:spPr>
-          <a:xfrm>
-            <a:off x="841248" y="5029200"/>
-            <a:ext cx="4754880" cy="316738"/>
-          </a:xfrm>
-          <a:prstGeom prst="rect">
-            <a:avLst/>
-          </a:prstGeom>
-          <a:noFill/>
-          <a:effectLst/>
-        </p:spPr>
-        <p:txBody>
-          <a:bodyPr wrap="none" anchor="t" lIns="0" rIns="0" tIns="0" bIns="0">
-            <a:noAutofit/>
-          </a:bodyPr>
-          <a:lstStyle/>
-          <a:p>
-            <a:pPr algn="l">
-              <a:lnSpc>
-                <a:spcPct val="118000"/>
-              </a:lnSpc>
-              <a:spcBef>
-                <a:spcPts val="0"/>
-              </a:spcBef>
-              <a:spcAft>
-                <a:spcPts val="0"/>
-              </a:spcAft>
-            </a:pPr>
-            <a:r>
-              <a:rPr sz="1900" b="1" lang="ko-KR">
-                <a:solidFill>
-                  <a:srgbClr val="007BC6"/>
-                </a:solidFill>
-                <a:latin typeface="Pretendard"/>
-                <a:ea typeface="Pretendard"/>
-                <a:cs typeface="Pretendard"/>
-              </a:rPr>
-              <a:t>02  긴 learning curve와 클래스별 F1</a:t>
-            </a:r>
-          </a:p>
-        </p:txBody>
-      </p:sp>
-      <p:sp>
-        <p:nvSpPr>
-          <p:cNvPr id="13" name="TextBox 12"/>
-          <p:cNvSpPr txBox="1"/>
-          <p:nvPr/>
-        </p:nvSpPr>
-        <p:spPr>
-          <a:xfrm>
-            <a:off x="6236208" y="5029200"/>
-            <a:ext cx="4754880" cy="316738"/>
-          </a:xfrm>
-          <a:prstGeom prst="rect">
-            <a:avLst/>
-          </a:prstGeom>
-          <a:noFill/>
-          <a:effectLst/>
-        </p:spPr>
-        <p:txBody>
-          <a:bodyPr wrap="none" anchor="t" lIns="0" rIns="0" tIns="0" bIns="0">
-            <a:noAutofit/>
-          </a:bodyPr>
-          <a:lstStyle/>
-          <a:p>
-            <a:pPr algn="l">
-              <a:lnSpc>
-                <a:spcPct val="118000"/>
-              </a:lnSpc>
-              <a:spcBef>
-                <a:spcPts val="0"/>
-              </a:spcBef>
-              <a:spcAft>
-                <a:spcPts val="0"/>
-              </a:spcAft>
-            </a:pPr>
-            <a:r>
-              <a:rPr sz="1900" b="1" lang="ko-KR">
-                <a:solidFill>
-                  <a:srgbClr val="B44948"/>
-                </a:solidFill>
-                <a:latin typeface="Pretendard"/>
-                <a:ea typeface="Pretendard"/>
-                <a:cs typeface="Pretendard"/>
-              </a:rPr>
-              <a:t>03  원본 CIC2018 CSV 행 감사</a:t>
-            </a:r>
-          </a:p>
-        </p:txBody>
-      </p:sp>
-      <p:sp>
-        <p:nvSpPr>
-          <p:cNvPr id="14" name="TextBox 13"/>
-          <p:cNvSpPr txBox="1"/>
-          <p:nvPr/>
-        </p:nvSpPr>
-        <p:spPr>
-          <a:xfrm>
-            <a:off x="841248" y="5541264"/>
-            <a:ext cx="10012680" cy="271779"/>
-          </a:xfrm>
-          <a:prstGeom prst="rect">
-            <a:avLst/>
-          </a:prstGeom>
-          <a:noFill/>
-          <a:effectLst/>
-        </p:spPr>
-        <p:txBody>
-          <a:bodyPr wrap="none" anchor="t" lIns="0" rIns="0" tIns="0" bIns="0">
-            <a:noAutofit/>
-          </a:bodyPr>
-          <a:lstStyle/>
-          <a:p>
-            <a:pPr algn="l">
-              <a:lnSpc>
-                <a:spcPct val="118000"/>
-              </a:lnSpc>
-              <a:spcBef>
-                <a:spcPts val="0"/>
-              </a:spcBef>
-              <a:spcAft>
-                <a:spcPts val="0"/>
-              </a:spcAft>
-            </a:pPr>
-            <a:r>
-              <a:rPr sz="1600" b="0" lang="ko-KR">
-                <a:solidFill>
-                  <a:srgbClr val="617080"/>
-                </a:solidFill>
-                <a:latin typeface="Pretendard"/>
-                <a:ea typeface="Pretendard"/>
-                <a:cs typeface="Pretendard"/>
-              </a:rPr>
-              <a:t>두 문제를 먼저 분리해 확인한 뒤, PCAP에서 새 표현을 만들고 같은 지표로 다시 측정</a:t>
-            </a:r>
-          </a:p>
-        </p:txBody>
-      </p:sp>
-      <p:sp>
-        <p:nvSpPr>
-          <p:cNvPr id="15" name="Rectangle 14"/>
-          <p:cNvSpPr/>
-          <p:nvPr/>
-        </p:nvSpPr>
-        <p:spPr>
-          <a:xfrm>
             <a:off x="0" y="6437376"/>
             <a:ext cx="12191999" cy="420624"/>
           </a:xfrm>
@@ -7229,7 +7039,7 @@
       </p:sp>
       <p:sp>
         <p:nvSpPr>
-          <p:cNvPr id="16" name="TextBox 15"/>
+          <p:cNvPr id="12" name="TextBox 11"/>
           <p:cNvSpPr txBox="1"/>
           <p:nvPr/>
         </p:nvSpPr>
@@ -7277,7 +7087,7 @@
       </p:sp>
       <p:sp>
         <p:nvSpPr>
-          <p:cNvPr id="17" name="TextBox 16"/>
+          <p:cNvPr id="13" name="TextBox 12"/>
           <p:cNvSpPr txBox="1"/>
           <p:nvPr/>
         </p:nvSpPr>
@@ -7325,7 +7135,7 @@
       </p:sp>
       <p:sp>
         <p:nvSpPr>
-          <p:cNvPr id="18" name="TextBox 17"/>
+          <p:cNvPr id="14" name="TextBox 13"/>
           <p:cNvSpPr txBox="1"/>
           <p:nvPr/>
         </p:nvSpPr>
@@ -11098,8 +10908,8 @@
         </p:blipFill>
         <p:spPr>
           <a:xfrm>
-            <a:off x="1000182" y="3227832"/>
-            <a:ext cx="10179443" cy="2029968"/>
+            <a:off x="1008415" y="3172968"/>
+            <a:ext cx="10162977" cy="2130552"/>
           </a:xfrm>
           <a:prstGeom prst="rect">
             <a:avLst/>
@@ -11115,8 +10925,8 @@
         </p:nvSpPr>
         <p:spPr>
           <a:xfrm>
-            <a:off x="658368" y="5513832"/>
-            <a:ext cx="10835640" cy="249301"/>
+            <a:off x="658368" y="5532120"/>
+            <a:ext cx="10835640" cy="238810"/>
           </a:xfrm>
           <a:prstGeom prst="rect">
             <a:avLst/>
@@ -11142,7 +10952,7 @@
               </a:spcAft>
             </a:pPr>
             <a:r>
-              <a:rPr sz="1450" b="0" lang="ko-KR">
+              <a:rPr sz="1380" b="0" lang="ko-KR">
                 <a:solidFill>
                   <a:srgbClr val="617080"/>
                 </a:solidFill>
@@ -11150,7 +10960,7 @@
                 <a:ea typeface="Pretendard"/>
                 <a:cs typeface="Pretendard"/>
               </a:rPr>
-              <a:t>원본 CSV 16,233,002행 전체 감사  ·  동일 feature·상이 label은 표현 한계 또는 라벨 근거를 재점검할 사례</a:t>
+              <a:t>CIC는 원본 CSV, ToN은 현재 NF-v3 46-feature 입력 기준  ·  동일 feature·상이 label은 표현 한계 또는 라벨 근거를 재점검할 사례</a:t>
             </a:r>
           </a:p>
         </p:txBody>

</xml_diff>

<commit_message>
focus CSV conflict slide on original CIC2018
</commit_message>
<xml_diff>
--- a/docs/slides/kor/20261029_PCAP_연구방향.pptx
+++ b/docs/slides/kor/20261029_PCAP_연구방향.pptx
@@ -777,7 +777,7 @@
           </a:p>
           <a:p>
             <a:r>
-              <a:t>위 표와 왼쪽 막대는 NF-v3 파생 입력이 아니라 원본 CIC2018 CICFlowMeter CSV 10개 파일 전체를 직접 감사한 결과다. Timestamp와 flow 식별자를 제외하고 모든 파일에 공통인 78개 통계 field가 같은 행을 묶었다. 위 표는 실제 원본 CSV 값이며, 보이는 열과 생략한 69개 field가 모두 같지만 label은 다르다. 오른쪽 ToN-IoT 막대는 원본 PCAP이나 모든 CSV field가 아니라 현재 실험이 쓰는 NF-v3 46개 input field와 Attack label로 계산했다. 두 막대는 상이 label feature group에 속한 행 수로 내림차순 정렬했고, 끝 숫자는 클래스 내 비율이다. 이 값은 모든 충돌을 같은 단일 원인이나 모든 라벨 오류로 단정하지 않는다. 다만 동일 통계 입력으로 하나의 분류기가 두 label을 동시에 맞힐 수 없으므로, 표현과 라벨 생성 근거를 함께 다시 점검해야 함을 보여 준다.</a:t>
+              <a:t>이 슬라이드는 NF-v3 파생 입력이 아니라 원본 CIC2018 CICFlowMeter CSV 10개 파일 전체를 직접 감사한 결과다. Timestamp와 flow 식별자를 제외하고 모든 파일에 공통인 78개 통계 field가 같은 행을 묶었다. 위 표는 실제 원본 CSV 값이며, 보이는 열과 생략한 69개 field가 모두 같지만 label은 다르다. 아래 막대는 class 전체 표본 수가 많은 순서로 정렬했다. 괄호는 그 class의 전체 행 수, 막대 길이와 끝 숫자는 그 class에서 동일 feature·상이 label group에 속한 비율과 행 수다. 이 값은 모든 충돌을 같은 단일 원인이나 모든 라벨 오류로 단정하지 않는다. 다만 동일 통계 입력으로 하나의 분류기가 두 label을 동시에 맞힐 수 없으므로, 표현과 라벨 생성 근거를 함께 다시 점검해야 함을 보여 준다.</a:t>
             </a:r>
           </a:p>
           <a:p/>
@@ -10908,8 +10908,8 @@
         </p:blipFill>
         <p:spPr>
           <a:xfrm>
-            <a:off x="1008415" y="3172968"/>
-            <a:ext cx="10162977" cy="2130552"/>
+            <a:off x="743376" y="3172968"/>
+            <a:ext cx="10693054" cy="2130552"/>
           </a:xfrm>
           <a:prstGeom prst="rect">
             <a:avLst/>
@@ -10960,7 +10960,7 @@
                 <a:ea typeface="Pretendard"/>
                 <a:cs typeface="Pretendard"/>
               </a:rPr>
-              <a:t>CIC는 원본 CSV, ToN은 현재 NF-v3 46-feature 입력 기준  ·  동일 feature·상이 label은 표현 한계 또는 라벨 근거를 재점검할 사례</a:t>
+              <a:t>원본 CSV 16,232,943행 전체 감사  ·  괄호는 class 전체 표본 수, 막대 끝은 해당 class의 상이 label 행 수</a:t>
             </a:r>
           </a:p>
         </p:txBody>

</xml_diff>

<commit_message>
Use NF-v3 families in CIC2018 conflict slide
</commit_message>
<xml_diff>
--- a/docs/slides/kor/20261029_PCAP_연구방향.pptx
+++ b/docs/slides/kor/20261029_PCAP_연구방향.pptx
@@ -777,7 +777,7 @@
           </a:p>
           <a:p>
             <a:r>
-              <a:t>이 슬라이드는 NF-v3 파생 입력이 아니라 원본 CIC2018 CICFlowMeter CSV 10개 파일 전체를 직접 감사한 결과다. Timestamp와 flow 식별자를 제외하고 모든 파일에 공통인 78개 통계 field가 같은 행을 묶었다. 위 표는 실제 원본 CSV 값이며, 보이는 열과 생략한 69개 field가 모두 같지만 label은 다르다. 아래 막대는 class 전체 표본 수가 많은 순서로 정렬했다. 괄호는 그 class의 전체 행 수, 막대 길이와 끝 숫자는 그 class에서 동일 feature·상이 label group에 속한 비율과 행 수다. 이 값은 모든 충돌을 같은 단일 원인이나 모든 라벨 오류로 단정하지 않는다. 다만 동일 통계 입력으로 하나의 분류기가 두 label을 동시에 맞힐 수 없으므로, 표현과 라벨 생성 근거를 함께 다시 점검해야 함을 보여 준다.</a:t>
+              <a:t>이 슬라이드는 NF-v3 파생 입력이 아니라 원본 CIC2018 CICFlowMeter CSV 10개 파일 전체를 직접 감사한 결과다. Timestamp와 flow 식별자를 제외하고 모든 파일에 공통인 78개 통계 field가 같은 행을 묶었다. 위 표는 실제 원본 CSV 값이며, 보이는 열과 생략한 69개 field가 모두 같지만 NF-v3 class는 다르다. 아래 막대는 NF-v3의 benign, ddos, bot, dos, bf, inf, web 순서다. 막대 길이와 끝 숫자는 해당 class에서 동일 feature·상이 class group에 속한 비율과 행 수다. 이 값은 모든 충돌을 같은 단일 원인이나 모든 라벨 오류로 단정하지 않는다. 다만 동일 통계 입력으로 하나의 분류기가 두 class를 동시에 맞힐 수 없으므로, 표현과 라벨 생성 근거를 함께 다시 점검해야 함을 보여 준다.</a:t>
             </a:r>
           </a:p>
           <a:p/>
@@ -7617,7 +7617,7 @@
                 <a:ea typeface="Pretendard"/>
                 <a:cs typeface="Pretendard"/>
               </a:rPr>
-              <a:t>원본 CIC2018 CSV의 동일 feature·상이 label</a:t>
+              <a:t>원본 CIC2018 CSV의 동일 feature·상이 class</a:t>
             </a:r>
           </a:p>
         </p:txBody>
@@ -8737,7 +8737,7 @@
         <p:spPr>
           <a:xfrm>
             <a:off x="10085832" y="1613916"/>
-            <a:ext cx="1463039" cy="178866"/>
+            <a:ext cx="1463039" cy="325729"/>
           </a:xfrm>
           <a:prstGeom prst="rect">
             <a:avLst/>
@@ -8771,7 +8771,31 @@
                 <a:ea typeface="Pretendard"/>
                 <a:cs typeface="Pretendard"/>
               </a:rPr>
-              <a:t>Label</a:t>
+              <a:t>NF-v3</a:t>
+            </a:r>
+          </a:p>
+          <a:p>
+            <a:pPr algn="ctr">
+              <a:lnSpc>
+                <a:spcPct val="118000"/>
+              </a:lnSpc>
+              <a:spcBef>
+                <a:spcPts val="0"/>
+              </a:spcBef>
+              <a:spcAft>
+                <a:spcPts val="0"/>
+              </a:spcAft>
+            </a:pPr>
+            <a:r>
+              <a:rPr sz="980" b="1" lang="ko-KR">
+                <a:solidFill>
+                  <a:srgbClr val="20262E"/>
+                </a:solidFill>
+                <a:latin typeface="Pretendard"/>
+                <a:ea typeface="Pretendard"/>
+                <a:cs typeface="Pretendard"/>
+              </a:rPr>
+              <a:t>class</a:t>
             </a:r>
           </a:p>
         </p:txBody>
@@ -9805,7 +9829,7 @@
                 <a:ea typeface="Pretendard"/>
                 <a:cs typeface="Pretendard"/>
               </a:rPr>
-              <a:t>DoS SlowHTTPTest</a:t>
+              <a:t>dos</a:t>
             </a:r>
           </a:p>
         </p:txBody>
@@ -10839,7 +10863,7 @@
                 <a:ea typeface="Pretendard"/>
                 <a:cs typeface="Pretendard"/>
               </a:rPr>
-              <a:t>FTP-BruteForce</a:t>
+              <a:t>bf</a:t>
             </a:r>
           </a:p>
         </p:txBody>
@@ -10887,7 +10911,7 @@
                 <a:ea typeface="Pretendard"/>
                 <a:cs typeface="Pretendard"/>
               </a:rPr>
-              <a:t>위 두 행: DoS SlowHTTPTest · FTP-BruteForce · SSH-Bruteforce  ·  가운데 생략 표시는 나머지 69개도 동일함</a:t>
+              <a:t>위 두 행: bf · dos  ·  가운데 생략 표시는 나머지 69개도 동일함</a:t>
             </a:r>
           </a:p>
         </p:txBody>
@@ -10908,8 +10932,8 @@
         </p:blipFill>
         <p:spPr>
           <a:xfrm>
-            <a:off x="743376" y="3172968"/>
-            <a:ext cx="10693054" cy="2130552"/>
+            <a:off x="1236979" y="3172968"/>
+            <a:ext cx="9705848" cy="2130552"/>
           </a:xfrm>
           <a:prstGeom prst="rect">
             <a:avLst/>
@@ -10960,7 +10984,7 @@
                 <a:ea typeface="Pretendard"/>
                 <a:cs typeface="Pretendard"/>
               </a:rPr>
-              <a:t>원본 CSV 16,232,943행 전체 감사  ·  괄호는 class 전체 표본 수, 막대 끝은 해당 class의 상이 label 행 수</a:t>
+              <a:t>원본 CSV 16,232,943행 전체 감사  ·  NF-v3 7개 class로 집계 · 막대 끝은 해당 class의 상이 class 행 수</a:t>
             </a:r>
           </a:p>
         </p:txBody>

</xml_diff>